<commit_message>
Add the delayed-order path that finishes as a refund or replacement.
Co-authored-by: Cursor <cursoragent@cursor.com>
</commit_message>
<xml_diff>
--- a/pitch/Kmart-Delivery-Assist-Lab12.pptx
+++ b/pitch/Kmart-Delivery-Assist-Lab12.pptx
@@ -7080,8 +7080,8 @@
                 </a:solidFill>
                 <a:latin typeface="Calibri"/>
               </a:rPr>
-              <a:t>Complete refund
-or replacement</a:t>
+              <a:t>Complete
+refund/replacement</a:t>
             </a:r>
           </a:p>
         </p:txBody>

</xml_diff>